<commit_message>
Update redirected endnote links; count exposure-limit refusals in the scorecard
Update redirected endnote links; count exposure-limit refusals in the scorecard
</commit_message>
<xml_diff>
--- a/deck/slides/the-ai-control-plane-slide-29.pptx
+++ b/deck/slides/the-ai-control-plane-slide-29.pptx
@@ -547,7 +547,7 @@
             </a:pPr>
             <a:r>
               <a:rPr lang="en-US" dirty="0"/>
-              <a:t>Leading indicators, one per metric, so delivery teams see movement within weeks: unregistered agents found (coverage), new agents launched behind the gateway (governed traffic), cost per successful task (cost per outcome) [60], spend attributed within a day (cost visibility), acceptance rate counting undo and revert as rejections (value) [60], blocked calls per 1,000 (policy enforcement), drill time (time to contain), tool-selection accuracy and plan adherence on sampled traces (eval pass rate) [60], verification latency (oversight coverage), takeover rate (oversight effectiveness) [60], and algorithm agility (crypto readiness). Evaluate the trajectory as well as the answer [60], and measure value instead of adoption. In BCG's 2026 survey of close to 12,000 employees and leaders, organizations with agents in their workflows rose from 13% to 30% in a year, yet half said governance for teams of people and AI is unclear [88].</a:t>
+              <a:t>Leading indicators, one per metric, so delivery teams see movement within weeks: unregistered agents found (coverage), new agents launched behind the gateway (governed traffic), cost per successful task (cost per outcome) [60], spend attributed within a day (cost visibility), acceptance rate counting undo and revert as rejections (value) [60], blocked calls per 1,000, with exposure-limit refusals counted separately (policy enforcement), drill time (time to contain), tool-selection accuracy and plan adherence on sampled traces (eval pass rate) [60], verification latency (oversight coverage), takeover rate (oversight effectiveness) [60], and algorithm agility (crypto readiness). Evaluate the trajectory as well as the answer [60], and measure value instead of adoption. In BCG's 2026 survey of close to 12,000 employees and leaders, organizations with agents in their workflows rose from 13% to 30% in a year, yet half said governance for teams of people and AI is unclear [88].</a:t>
             </a:r>
           </a:p>
           <a:p>
@@ -790,7 +790,7 @@
             </a:pPr>
             <a:r>
               <a:rPr lang="en-US" dirty="0"/>
-              <a:t>Data sources in Agent Fabric: Agent Registry (coverage, owners, tiers), AI Gateway and LLM Governance (traffic, tokens, cost, cost attribution, policy events), Agent Kill Switch and Trusted Agent Identity (containment and authorization records), Agent Visualizer and evaluation results (quality and risk signals). Oversight effectiveness comes from the approval-binding policy's events and from kill-switch and approver drill records. Coverage counts who is assigned, while effectiveness shows they could intervene in time [30][31][32]. Value realized comes from business-case tracking agreed with finance: the run-rate value of each live use-case slice against its plan, reported at every milestone.</a:t>
+              <a:t>Data sources in Agent Fabric: Agent Registry (coverage, owners, tiers), AI Gateway and LLM Governance (traffic, tokens, cost, cost attribution, policy events), Agent Kill Switch and Trusted Agent Identity (containment and authorization records), Agent Visualizer and evaluation results (quality and risk signals). Oversight effectiveness comes from the approval-binding policy's events and from kill-switch and approver drill records. Policy enforcement also counts the exposure-limit breaches that the custom aggregate-risk policy refuses, so the scorecard tracks limits on what agents do as well as on what they spend. Coverage counts who is assigned, while effectiveness shows they could intervene in time [30][31][32]. Value realized comes from business-case tracking agreed with finance: the run-rate value of each live use-case slice against its plan, reported at every milestone.</a:t>
             </a:r>
           </a:p>
           <a:p>
@@ -2576,7 +2576,7 @@
                 <a:ea typeface="Plus Jakarta Sans" pitchFamily="34" charset="-122"/>
                 <a:cs typeface="Plus Jakarta Sans" pitchFamily="34" charset="-120"/>
               </a:rPr>
-              <a:t>Violations blocked before impact versus found afterward</a:t>
+              <a:t>Violations, including exposure-limit breaches, blocked before impact versus found afterward</a:t>
             </a:r>
             <a:endParaRPr lang="en-US" sz="950" dirty="0"/>
           </a:p>

</xml_diff>